<commit_message>
Add weekly report 2026-04-19: .md + .pptx
</commit_message>
<xml_diff>
--- a/report_2026-04-19.pptx
+++ b/report_2026-04-19.pptx
@@ -1485,7 +1485,7 @@
                 <a:ea typeface="Trebuchet MS" pitchFamily="34" charset="-122"/>
                 <a:cs typeface="Trebuchet MS" pitchFamily="34" charset="-120"/>
               </a:rPr>
-              <a:t>Global Retail AI Transformation Weekly Intelligence Report</a:t>
+              <a:t>Global Retail AI Transformation Intelligence Report</a:t>
             </a:r>
             <a:endParaRPr lang="en-US" sz="3200" dirty="0"/>
           </a:p>
@@ -1564,7 +1564,7 @@
         <p:spPr>
           <a:xfrm>
             <a:off x="548640" y="4133088"/>
-            <a:ext cx="5486400" cy="256032"/>
+            <a:ext cx="7315200" cy="256032"/>
           </a:xfrm>
           <a:prstGeom prst="rect">
             <a:avLst/>
@@ -1588,7 +1588,7 @@
                 <a:ea typeface="Calibri" pitchFamily="34" charset="-122"/>
                 <a:cs typeface="Calibri" pitchFamily="34" charset="-120"/>
               </a:rPr>
-              <a:t>April 19, 2026  |  Week of April 13–19, 2026</a:t>
+              <a:t>April 19, 2026  ·  Senior Executive Leadership — IKEA Group</a:t>
             </a:r>
             <a:endParaRPr lang="en-US" sz="1100" dirty="0"/>
           </a:p>
@@ -1827,7 +1827,7 @@
         <p:spPr>
           <a:xfrm>
             <a:off x="457200" y="868680"/>
-            <a:ext cx="8229600" cy="1417320"/>
+            <a:ext cx="8229600" cy="1508760"/>
           </a:xfrm>
           <a:prstGeom prst="rect">
             <a:avLst/>
@@ -1859,7 +1859,7 @@
         <p:spPr>
           <a:xfrm>
             <a:off x="457200" y="868680"/>
-            <a:ext cx="73152" cy="1417320"/>
+            <a:ext cx="73152" cy="1508760"/>
           </a:xfrm>
           <a:prstGeom prst="rect">
             <a:avLst/>
@@ -1884,7 +1884,7 @@
         <p:spPr>
           <a:xfrm>
             <a:off x="685800" y="914400"/>
-            <a:ext cx="7818120" cy="1325880"/>
+            <a:ext cx="7818120" cy="1417320"/>
           </a:xfrm>
           <a:prstGeom prst="rect">
             <a:avLst/>
@@ -1898,12 +1898,12 @@
           <a:p>
             <a:pPr algn="l" indent="0" marL="0">
               <a:lnSpc>
-                <a:spcPct val="145000"/>
+                <a:spcPct val="140000"/>
               </a:lnSpc>
               <a:buNone/>
             </a:pPr>
             <a:r>
-              <a:rPr lang="en-US" sz="1400" dirty="0">
+              <a:rPr lang="en-US" sz="1350" dirty="0">
                 <a:solidFill>
                   <a:srgbClr val="FFFFFF"/>
                 </a:solidFill>
@@ -1911,9 +1911,9 @@
                 <a:ea typeface="Calibri" pitchFamily="34" charset="-122"/>
                 <a:cs typeface="Calibri" pitchFamily="34" charset="-120"/>
               </a:rPr>
-              <a:t>Global retail AI has decisively shifted from experimentation to scaled execution: Walmart completes the largest in-store digital pricing infrastructure deployment in retail history; Amazon advances AI-orchestrated physical-digital superstores; Sephora embeds brand expertise inside conversational AI; and JD.com and Alibaba extend their AI rivalry into healthcare — signaling that AI infrastructure, not price or assortment, is now the primary competitive battleground in global retail for 2026.</a:t>
-            </a:r>
-            <a:endParaRPr lang="en-US" sz="1400" dirty="0"/>
+              <a:t>This week's global retail AI landscape is defined by an accelerating convergence of agentic AI, physical store reinvention, and cross-platform conversational commerce — as Walmart and Amazon double down on infrastructure-scale automation, Sephora brings ChatGPT-native shopping to 80+ million beauty members, and Chinese platforms JD.com and Douyin deepen AI ecosystems into healthcare and luxury, all against the backdrop of escalating US tariff pressures reshaping supply chain investment strategies worldwide.</a:t>
+            </a:r>
+            <a:endParaRPr lang="en-US" sz="1350" dirty="0"/>
           </a:p>
         </p:txBody>
       </p:sp>
@@ -1925,7 +1925,7 @@
         </p:nvSpPr>
         <p:spPr>
           <a:xfrm>
-            <a:off x="502920" y="2487168"/>
+            <a:off x="502920" y="2578608"/>
             <a:ext cx="4572000" cy="292608"/>
           </a:xfrm>
           <a:prstGeom prst="rect">
@@ -1964,7 +1964,7 @@
         </p:nvSpPr>
         <p:spPr>
           <a:xfrm>
-            <a:off x="457200" y="2852928"/>
+            <a:off x="457200" y="2944368"/>
             <a:ext cx="1965960" cy="502920"/>
           </a:xfrm>
           <a:prstGeom prst="rect">
@@ -1989,7 +1989,7 @@
         </p:nvSpPr>
         <p:spPr>
           <a:xfrm>
-            <a:off x="457200" y="2852928"/>
+            <a:off x="457200" y="2944368"/>
             <a:ext cx="1965960" cy="502920"/>
           </a:xfrm>
           <a:prstGeom prst="rect">
@@ -2028,7 +2028,7 @@
         </p:nvSpPr>
         <p:spPr>
           <a:xfrm>
-            <a:off x="2542032" y="2852928"/>
+            <a:off x="2542032" y="2944368"/>
             <a:ext cx="1965960" cy="502920"/>
           </a:xfrm>
           <a:prstGeom prst="rect">
@@ -2053,7 +2053,7 @@
         </p:nvSpPr>
         <p:spPr>
           <a:xfrm>
-            <a:off x="2542032" y="2852928"/>
+            <a:off x="2542032" y="2944368"/>
             <a:ext cx="1965960" cy="502920"/>
           </a:xfrm>
           <a:prstGeom prst="rect">
@@ -2092,7 +2092,7 @@
         </p:nvSpPr>
         <p:spPr>
           <a:xfrm>
-            <a:off x="4626864" y="2852928"/>
+            <a:off x="4626864" y="2944368"/>
             <a:ext cx="1965960" cy="502920"/>
           </a:xfrm>
           <a:prstGeom prst="rect">
@@ -2117,7 +2117,7 @@
         </p:nvSpPr>
         <p:spPr>
           <a:xfrm>
-            <a:off x="4626864" y="2852928"/>
+            <a:off x="4626864" y="2944368"/>
             <a:ext cx="1965960" cy="502920"/>
           </a:xfrm>
           <a:prstGeom prst="rect">
@@ -2156,7 +2156,7 @@
         </p:nvSpPr>
         <p:spPr>
           <a:xfrm>
-            <a:off x="6711696" y="2852928"/>
+            <a:off x="6711696" y="2944368"/>
             <a:ext cx="1965960" cy="502920"/>
           </a:xfrm>
           <a:prstGeom prst="rect">
@@ -2181,7 +2181,7 @@
         </p:nvSpPr>
         <p:spPr>
           <a:xfrm>
-            <a:off x="6711696" y="2852928"/>
+            <a:off x="6711696" y="2944368"/>
             <a:ext cx="1965960" cy="502920"/>
           </a:xfrm>
           <a:prstGeom prst="rect">
@@ -2220,7 +2220,7 @@
         </p:nvSpPr>
         <p:spPr>
           <a:xfrm>
-            <a:off x="457200" y="3511296"/>
+            <a:off x="457200" y="3602736"/>
             <a:ext cx="1965960" cy="502920"/>
           </a:xfrm>
           <a:prstGeom prst="rect">
@@ -2245,7 +2245,7 @@
         </p:nvSpPr>
         <p:spPr>
           <a:xfrm>
-            <a:off x="457200" y="3511296"/>
+            <a:off x="457200" y="3602736"/>
             <a:ext cx="1965960" cy="502920"/>
           </a:xfrm>
           <a:prstGeom prst="rect">
@@ -2284,7 +2284,7 @@
         </p:nvSpPr>
         <p:spPr>
           <a:xfrm>
-            <a:off x="2542032" y="3511296"/>
+            <a:off x="2542032" y="3602736"/>
             <a:ext cx="1965960" cy="502920"/>
           </a:xfrm>
           <a:prstGeom prst="rect">
@@ -2309,7 +2309,7 @@
         </p:nvSpPr>
         <p:spPr>
           <a:xfrm>
-            <a:off x="2542032" y="3511296"/>
+            <a:off x="2542032" y="3602736"/>
             <a:ext cx="1965960" cy="502920"/>
           </a:xfrm>
           <a:prstGeom prst="rect">
@@ -2334,7 +2334,7 @@
                 <a:ea typeface="Trebuchet MS" pitchFamily="34" charset="-122"/>
                 <a:cs typeface="Trebuchet MS" pitchFamily="34" charset="-120"/>
               </a:rPr>
-              <a:t>Dollar General</a:t>
+              <a:t>Douyin</a:t>
             </a:r>
             <a:endParaRPr lang="en-US" sz="1200" dirty="0"/>
           </a:p>
@@ -2533,7 +2533,7 @@
                 <a:ea typeface="Calibri" pitchFamily="34" charset="-122"/>
                 <a:cs typeface="Calibri" pitchFamily="34" charset="-120"/>
               </a:rPr>
-              <a:t>Ranked by strategic importance  ·  Week of April 13–19, 2026</a:t>
+              <a:t>Ranked by strategic importance · Week of April 13–19, 2026</a:t>
             </a:r>
             <a:endParaRPr lang="en-US" sz="1100" dirty="0"/>
           </a:p>
@@ -2548,7 +2548,7 @@
         <p:spPr>
           <a:xfrm>
             <a:off x="365760" y="1078992"/>
-            <a:ext cx="4251960" cy="1389888"/>
+            <a:ext cx="4251960" cy="1335024"/>
           </a:xfrm>
           <a:prstGeom prst="rect">
             <a:avLst/>
@@ -2577,7 +2577,7 @@
         <p:spPr>
           <a:xfrm>
             <a:off x="365760" y="1078992"/>
-            <a:ext cx="50292" cy="1389888"/>
+            <a:ext cx="50292" cy="1335024"/>
           </a:xfrm>
           <a:prstGeom prst="rect">
             <a:avLst/>
@@ -2601,8 +2601,8 @@
         </p:nvSpPr>
         <p:spPr>
           <a:xfrm>
-            <a:off x="530352" y="1170432"/>
-            <a:ext cx="3977640" cy="292608"/>
+            <a:off x="530352" y="1152144"/>
+            <a:ext cx="3977640" cy="274320"/>
           </a:xfrm>
           <a:prstGeom prst="rect">
             <a:avLst/>
@@ -2618,7 +2618,7 @@
               <a:buNone/>
             </a:pPr>
             <a:r>
-              <a:rPr lang="en-US" sz="1200" b="1" dirty="0">
+              <a:rPr lang="en-US" sz="1150" b="1" dirty="0">
                 <a:solidFill>
                   <a:srgbClr val="FFDA00"/>
                 </a:solidFill>
@@ -2628,7 +2628,7 @@
               </a:rPr>
               <a:t>Walmart  USA</a:t>
             </a:r>
-            <a:endParaRPr lang="en-US" sz="1200" dirty="0"/>
+            <a:endParaRPr lang="en-US" sz="1150" dirty="0"/>
           </a:p>
         </p:txBody>
       </p:sp>
@@ -2640,7 +2640,7 @@
         </p:nvSpPr>
         <p:spPr>
           <a:xfrm>
-            <a:off x="530352" y="1490472"/>
+            <a:off x="530352" y="1463040"/>
             <a:ext cx="3977640" cy="475488"/>
           </a:xfrm>
           <a:prstGeom prst="rect">
@@ -2660,7 +2660,7 @@
               <a:buNone/>
             </a:pPr>
             <a:r>
-              <a:rPr lang="en-US" sz="1000" dirty="0">
+              <a:rPr lang="en-US" sz="950" dirty="0">
                 <a:solidFill>
                   <a:srgbClr val="FFFFFF"/>
                 </a:solidFill>
@@ -2668,9 +2668,9 @@
                 <a:ea typeface="Calibri" pitchFamily="34" charset="-122"/>
                 <a:cs typeface="Calibri" pitchFamily="34" charset="-120"/>
               </a:rPr>
-              <a:t>DSL rollout to all 4,600+ stores by year-end; AI training for 1.6M associates via OpenAI/Walmart Academy; Sparky agent + Gemini integration</a:t>
-            </a:r>
-            <a:endParaRPr lang="en-US" sz="1000" dirty="0"/>
+              <a:t>Agentic commerce at infrastructure scale: Sparky + Marty AI agents, ChatGPT/Gemini integration, UCP membership, DSL roll</a:t>
+            </a:r>
+            <a:endParaRPr lang="en-US" sz="950" dirty="0"/>
           </a:p>
         </p:txBody>
       </p:sp>
@@ -2682,7 +2682,7 @@
         </p:nvSpPr>
         <p:spPr>
           <a:xfrm>
-            <a:off x="530352" y="1993392"/>
+            <a:off x="530352" y="1975104"/>
             <a:ext cx="3977640" cy="347472"/>
           </a:xfrm>
           <a:prstGeom prst="rect">
@@ -2699,7 +2699,7 @@
               <a:buNone/>
             </a:pPr>
             <a:r>
-              <a:rPr lang="en-US" sz="950" dirty="0">
+              <a:rPr lang="en-US" sz="900" dirty="0">
                 <a:solidFill>
                   <a:srgbClr val="CBD5E1"/>
                 </a:solidFill>
@@ -2707,9 +2707,9 @@
                 <a:ea typeface="Calibri" pitchFamily="34" charset="-122"/>
                 <a:cs typeface="Calibri" pitchFamily="34" charset="-120"/>
               </a:rPr>
-              <a:t>▶  75% reduction in associate pricing task time; ~€1B VusionGroup contract</a:t>
-            </a:r>
-            <a:endParaRPr lang="en-US" sz="950" dirty="0"/>
+              <a:t>▶  eCommerce +27% YoY; 50% of e-fulfillment automated; advertising +37% globally; P/E 40.3x — reframed </a:t>
+            </a:r>
+            <a:endParaRPr lang="en-US" sz="900" dirty="0"/>
           </a:p>
         </p:txBody>
       </p:sp>
@@ -2722,7 +2722,7 @@
         <p:spPr>
           <a:xfrm>
             <a:off x="4828032" y="1078992"/>
-            <a:ext cx="4251960" cy="1389888"/>
+            <a:ext cx="4251960" cy="1335024"/>
           </a:xfrm>
           <a:prstGeom prst="rect">
             <a:avLst/>
@@ -2751,7 +2751,7 @@
         <p:spPr>
           <a:xfrm>
             <a:off x="4828032" y="1078992"/>
-            <a:ext cx="50292" cy="1389888"/>
+            <a:ext cx="50292" cy="1335024"/>
           </a:xfrm>
           <a:prstGeom prst="rect">
             <a:avLst/>
@@ -2775,8 +2775,8 @@
         </p:nvSpPr>
         <p:spPr>
           <a:xfrm>
-            <a:off x="4992624" y="1170432"/>
-            <a:ext cx="3977640" cy="292608"/>
+            <a:off x="4992624" y="1152144"/>
+            <a:ext cx="3977640" cy="274320"/>
           </a:xfrm>
           <a:prstGeom prst="rect">
             <a:avLst/>
@@ -2792,7 +2792,7 @@
               <a:buNone/>
             </a:pPr>
             <a:r>
-              <a:rPr lang="en-US" sz="1200" b="1" dirty="0">
+              <a:rPr lang="en-US" sz="1150" b="1" dirty="0">
                 <a:solidFill>
                   <a:srgbClr val="FFDA00"/>
                 </a:solidFill>
@@ -2802,7 +2802,7 @@
               </a:rPr>
               <a:t>Amazon  USA</a:t>
             </a:r>
-            <a:endParaRPr lang="en-US" sz="1200" dirty="0"/>
+            <a:endParaRPr lang="en-US" sz="1150" dirty="0"/>
           </a:p>
         </p:txBody>
       </p:sp>
@@ -2814,7 +2814,7 @@
         </p:nvSpPr>
         <p:spPr>
           <a:xfrm>
-            <a:off x="4992624" y="1490472"/>
+            <a:off x="4992624" y="1463040"/>
             <a:ext cx="3977640" cy="475488"/>
           </a:xfrm>
           <a:prstGeom prst="rect">
@@ -2834,7 +2834,7 @@
               <a:buNone/>
             </a:pPr>
             <a:r>
-              <a:rPr lang="en-US" sz="1000" dirty="0">
+              <a:rPr lang="en-US" sz="950" dirty="0">
                 <a:solidFill>
                   <a:srgbClr val="FFFFFF"/>
                 </a:solidFill>
@@ -2842,9 +2842,9 @@
                 <a:ea typeface="Calibri" pitchFamily="34" charset="-122"/>
                 <a:cs typeface="Calibri" pitchFamily="34" charset="-120"/>
               </a:rPr>
-              <a:t>Project Kobe: 225,000 sq ft AI-robotics superstores; Frida AI inventory assistant; Rufus 'Auto Buy' agentic commerce; $200B AI spend 2026</a:t>
-            </a:r>
-            <a:endParaRPr lang="en-US" sz="1000" dirty="0"/>
+              <a:t>Project Kobe AI+robotics supercenter (250K SKUs); Blue Jay multi-arm robots; Project Eluna agentic AI for fulfillment op</a:t>
+            </a:r>
+            <a:endParaRPr lang="en-US" sz="950" dirty="0"/>
           </a:p>
         </p:txBody>
       </p:sp>
@@ -2856,7 +2856,7 @@
         </p:nvSpPr>
         <p:spPr>
           <a:xfrm>
-            <a:off x="4992624" y="1993392"/>
+            <a:off x="4992624" y="1975104"/>
             <a:ext cx="3977640" cy="347472"/>
           </a:xfrm>
           <a:prstGeom prst="rect">
@@ -2873,7 +2873,7 @@
               <a:buNone/>
             </a:pPr>
             <a:r>
-              <a:rPr lang="en-US" sz="950" dirty="0">
+              <a:rPr lang="en-US" sz="900" dirty="0">
                 <a:solidFill>
                   <a:srgbClr val="CBD5E1"/>
                 </a:solidFill>
@@ -2881,9 +2881,9 @@
                 <a:ea typeface="Calibri" pitchFamily="34" charset="-122"/>
                 <a:cs typeface="Calibri" pitchFamily="34" charset="-120"/>
               </a:rPr>
-              <a:t>▶  Rufus: 60% higher purchase rate, $10B+ incremental annual sales; 3% vs Walmart's 21% grocery share</a:t>
-            </a:r>
-            <a:endParaRPr lang="en-US" sz="950" dirty="0"/>
+              <a:t>▶  Blue Jay handles 75% of items; Eluna live in TN; Bedrock used by 100K+ companies; Project Leo satell</a:t>
+            </a:r>
+            <a:endParaRPr lang="en-US" sz="900" dirty="0"/>
           </a:p>
         </p:txBody>
       </p:sp>
@@ -2895,8 +2895,8 @@
         </p:nvSpPr>
         <p:spPr>
           <a:xfrm>
-            <a:off x="365760" y="2615184"/>
-            <a:ext cx="4251960" cy="1389888"/>
+            <a:off x="365760" y="2560320"/>
+            <a:ext cx="4251960" cy="1335024"/>
           </a:xfrm>
           <a:prstGeom prst="rect">
             <a:avLst/>
@@ -2924,8 +2924,8 @@
         </p:nvSpPr>
         <p:spPr>
           <a:xfrm>
-            <a:off x="365760" y="2615184"/>
-            <a:ext cx="50292" cy="1389888"/>
+            <a:off x="365760" y="2560320"/>
+            <a:ext cx="50292" cy="1335024"/>
           </a:xfrm>
           <a:prstGeom prst="rect">
             <a:avLst/>
@@ -2949,8 +2949,8 @@
         </p:nvSpPr>
         <p:spPr>
           <a:xfrm>
-            <a:off x="530352" y="2706624"/>
-            <a:ext cx="3977640" cy="292608"/>
+            <a:off x="530352" y="2633472"/>
+            <a:ext cx="3977640" cy="274320"/>
           </a:xfrm>
           <a:prstGeom prst="rect">
             <a:avLst/>
@@ -2966,7 +2966,7 @@
               <a:buNone/>
             </a:pPr>
             <a:r>
-              <a:rPr lang="en-US" sz="1200" b="1" dirty="0">
+              <a:rPr lang="en-US" sz="1150" b="1" dirty="0">
                 <a:solidFill>
                   <a:srgbClr val="FFDA00"/>
                 </a:solidFill>
@@ -2974,9 +2974,9 @@
                 <a:ea typeface="Trebuchet MS" pitchFamily="34" charset="-122"/>
                 <a:cs typeface="Trebuchet MS" pitchFamily="34" charset="-120"/>
               </a:rPr>
-              <a:t>Sephora  France/Global</a:t>
-            </a:r>
-            <a:endParaRPr lang="en-US" sz="1200" dirty="0"/>
+              <a:t>Sephora  USA/Global</a:t>
+            </a:r>
+            <a:endParaRPr lang="en-US" sz="1150" dirty="0"/>
           </a:p>
         </p:txBody>
       </p:sp>
@@ -2988,7 +2988,7 @@
         </p:nvSpPr>
         <p:spPr>
           <a:xfrm>
-            <a:off x="530352" y="3026664"/>
+            <a:off x="530352" y="2944368"/>
             <a:ext cx="3977640" cy="475488"/>
           </a:xfrm>
           <a:prstGeom prst="rect">
@@ -3008,7 +3008,7 @@
               <a:buNone/>
             </a:pPr>
             <a:r>
-              <a:rPr lang="en-US" sz="1000" dirty="0">
+              <a:rPr lang="en-US" sz="950" dirty="0">
                 <a:solidFill>
                   <a:srgbClr val="FFFFFF"/>
                 </a:solidFill>
@@ -3016,9 +3016,9 @@
                 <a:ea typeface="Calibri" pitchFamily="34" charset="-122"/>
                 <a:cs typeface="Calibri" pitchFamily="34" charset="-120"/>
               </a:rPr>
-              <a:t>ChatGPT app launch (Mar 2026): personalized beauty discovery, Beauty Insider integration, checkout planned; AI demand forecasting + digital twin supply chain</a:t>
-            </a:r>
-            <a:endParaRPr lang="en-US" sz="1000" dirty="0"/>
+              <a:t>ChatGPT-native shopping app launched for 80M+ Beauty Insider members; AI trend forecasting; UK omnichannel scale-up to 2</a:t>
+            </a:r>
+            <a:endParaRPr lang="en-US" sz="950" dirty="0"/>
           </a:p>
         </p:txBody>
       </p:sp>
@@ -3030,7 +3030,7 @@
         </p:nvSpPr>
         <p:spPr>
           <a:xfrm>
-            <a:off x="530352" y="3529584"/>
+            <a:off x="530352" y="3456432"/>
             <a:ext cx="3977640" cy="347472"/>
           </a:xfrm>
           <a:prstGeom prst="rect">
@@ -3047,7 +3047,7 @@
               <a:buNone/>
             </a:pPr>
             <a:r>
-              <a:rPr lang="en-US" sz="950" dirty="0">
+              <a:rPr lang="en-US" sz="900" dirty="0">
                 <a:solidFill>
                   <a:srgbClr val="CBD5E1"/>
                 </a:solidFill>
@@ -3055,9 +3055,9 @@
                 <a:ea typeface="Calibri" pitchFamily="34" charset="-122"/>
                 <a:cs typeface="Calibri" pitchFamily="34" charset="-120"/>
               </a:rPr>
-              <a:t>▶  UK expanding to 20 stores 2026; OpenAI exploring broader global collaboration</a:t>
-            </a:r>
-            <a:endParaRPr lang="en-US" sz="950" dirty="0"/>
+              <a:t>▶  AI trend forecasting shortened launch cycles 30–40%; Shoptalk 2026 joint keynote with OpenAI</a:t>
+            </a:r>
+            <a:endParaRPr lang="en-US" sz="900" dirty="0"/>
           </a:p>
         </p:txBody>
       </p:sp>
@@ -3069,8 +3069,8 @@
         </p:nvSpPr>
         <p:spPr>
           <a:xfrm>
-            <a:off x="4828032" y="2615184"/>
-            <a:ext cx="4251960" cy="1389888"/>
+            <a:off x="4828032" y="2560320"/>
+            <a:ext cx="4251960" cy="1335024"/>
           </a:xfrm>
           <a:prstGeom prst="rect">
             <a:avLst/>
@@ -3098,8 +3098,8 @@
         </p:nvSpPr>
         <p:spPr>
           <a:xfrm>
-            <a:off x="4828032" y="2615184"/>
-            <a:ext cx="50292" cy="1389888"/>
+            <a:off x="4828032" y="2560320"/>
+            <a:ext cx="50292" cy="1335024"/>
           </a:xfrm>
           <a:prstGeom prst="rect">
             <a:avLst/>
@@ -3123,8 +3123,8 @@
         </p:nvSpPr>
         <p:spPr>
           <a:xfrm>
-            <a:off x="4992624" y="2706624"/>
-            <a:ext cx="3977640" cy="292608"/>
+            <a:off x="4992624" y="2633472"/>
+            <a:ext cx="3977640" cy="274320"/>
           </a:xfrm>
           <a:prstGeom prst="rect">
             <a:avLst/>
@@ -3140,7 +3140,7 @@
               <a:buNone/>
             </a:pPr>
             <a:r>
-              <a:rPr lang="en-US" sz="1200" b="1" dirty="0">
+              <a:rPr lang="en-US" sz="1150" b="1" dirty="0">
                 <a:solidFill>
                   <a:srgbClr val="FFDA00"/>
                 </a:solidFill>
@@ -3150,7 +3150,7 @@
               </a:rPr>
               <a:t>JD.com  China</a:t>
             </a:r>
-            <a:endParaRPr lang="en-US" sz="1200" dirty="0"/>
+            <a:endParaRPr lang="en-US" sz="1150" dirty="0"/>
           </a:p>
         </p:txBody>
       </p:sp>
@@ -3162,7 +3162,7 @@
         </p:nvSpPr>
         <p:spPr>
           <a:xfrm>
-            <a:off x="4992624" y="3026664"/>
+            <a:off x="4992624" y="2944368"/>
             <a:ext cx="3977640" cy="475488"/>
           </a:xfrm>
           <a:prstGeom prst="rect">
@@ -3182,7 +3182,7 @@
               <a:buNone/>
             </a:pPr>
             <a:r>
-              <a:rPr lang="en-US" sz="1000" dirty="0">
+              <a:rPr lang="en-US" sz="950" dirty="0">
                 <a:solidFill>
                   <a:srgbClr val="FFFFFF"/>
                 </a:solidFill>
@@ -3190,9 +3190,9 @@
                 <a:ea typeface="Calibri" pitchFamily="34" charset="-122"/>
                 <a:cs typeface="Calibri" pitchFamily="34" charset="-120"/>
               </a:rPr>
-              <a:t>JD Health 'AI + Medical Devices' strategy (Apr 9): JoyInside into 1M devices; JoyAI engine 3,000 tokens/sec — ranked 2nd globally; digital human platform 4.0</a:t>
-            </a:r>
-            <a:endParaRPr lang="en-US" sz="1000" dirty="0"/>
+              <a:t>AI+Medical Devices strategy: JoyInside into 1M devices in 12 months; JoyAI ecosystem; digital human platform 4.0 cuts st</a:t>
+            </a:r>
+            <a:endParaRPr lang="en-US" sz="950" dirty="0"/>
           </a:p>
         </p:txBody>
       </p:sp>
@@ -3204,7 +3204,7 @@
         </p:nvSpPr>
         <p:spPr>
           <a:xfrm>
-            <a:off x="4992624" y="3529584"/>
+            <a:off x="4992624" y="3456432"/>
             <a:ext cx="3977640" cy="347472"/>
           </a:xfrm>
           <a:prstGeom prst="rect">
@@ -3221,7 +3221,7 @@
               <a:buNone/>
             </a:pPr>
             <a:r>
-              <a:rPr lang="en-US" sz="950" dirty="0">
+              <a:rPr lang="en-US" sz="900" dirty="0">
                 <a:solidFill>
                   <a:srgbClr val="CBD5E1"/>
                 </a:solidFill>
@@ -3229,9 +3229,9 @@
                 <a:ea typeface="Calibri" pitchFamily="34" charset="-122"/>
                 <a:cs typeface="Calibri" pitchFamily="34" charset="-120"/>
               </a:rPr>
-              <a:t>▶  Live streaming costs cut 90%; 13 consecutive quarters of gross margin expansion</a:t>
-            </a:r>
-            <a:endParaRPr lang="en-US" sz="950" dirty="0"/>
+              <a:t>▶  JoyAI inference engine 3,000 tokens/sec/card (1.8x), ranked #2 globally; trillion-yuan AI plan over </a:t>
+            </a:r>
+            <a:endParaRPr lang="en-US" sz="900" dirty="0"/>
           </a:p>
         </p:txBody>
       </p:sp>
@@ -3243,8 +3243,8 @@
         </p:nvSpPr>
         <p:spPr>
           <a:xfrm>
-            <a:off x="365760" y="4151376"/>
-            <a:ext cx="4251960" cy="1389888"/>
+            <a:off x="365760" y="4041648"/>
+            <a:ext cx="4251960" cy="1335024"/>
           </a:xfrm>
           <a:prstGeom prst="rect">
             <a:avLst/>
@@ -3272,8 +3272,8 @@
         </p:nvSpPr>
         <p:spPr>
           <a:xfrm>
-            <a:off x="365760" y="4151376"/>
-            <a:ext cx="50292" cy="1389888"/>
+            <a:off x="365760" y="4041648"/>
+            <a:ext cx="50292" cy="1335024"/>
           </a:xfrm>
           <a:prstGeom prst="rect">
             <a:avLst/>
@@ -3297,8 +3297,8 @@
         </p:nvSpPr>
         <p:spPr>
           <a:xfrm>
-            <a:off x="530352" y="4242816"/>
-            <a:ext cx="3977640" cy="292608"/>
+            <a:off x="530352" y="4114800"/>
+            <a:ext cx="3977640" cy="274320"/>
           </a:xfrm>
           <a:prstGeom prst="rect">
             <a:avLst/>
@@ -3314,7 +3314,7 @@
               <a:buNone/>
             </a:pPr>
             <a:r>
-              <a:rPr lang="en-US" sz="1200" b="1" dirty="0">
+              <a:rPr lang="en-US" sz="1150" b="1" dirty="0">
                 <a:solidFill>
                   <a:srgbClr val="FFDA00"/>
                 </a:solidFill>
@@ -3322,9 +3322,9 @@
                 <a:ea typeface="Trebuchet MS" pitchFamily="34" charset="-122"/>
                 <a:cs typeface="Trebuchet MS" pitchFamily="34" charset="-120"/>
               </a:rPr>
-              <a:t>Alibaba  China</a:t>
-            </a:r>
-            <a:endParaRPr lang="en-US" sz="1200" dirty="0"/>
+              <a:t>Alibaba/Meituan  China</a:t>
+            </a:r>
+            <a:endParaRPr lang="en-US" sz="1150" dirty="0"/>
           </a:p>
         </p:txBody>
       </p:sp>
@@ -3336,7 +3336,7 @@
         </p:nvSpPr>
         <p:spPr>
           <a:xfrm>
-            <a:off x="530352" y="4562856"/>
+            <a:off x="530352" y="4425696"/>
             <a:ext cx="3977640" cy="475488"/>
           </a:xfrm>
           <a:prstGeom prst="rect">
@@ -3356,7 +3356,7 @@
               <a:buNone/>
             </a:pPr>
             <a:r>
-              <a:rPr lang="en-US" sz="1000" dirty="0">
+              <a:rPr lang="en-US" sz="950" dirty="0">
                 <a:solidFill>
                   <a:srgbClr val="FFFFFF"/>
                 </a:solidFill>
@@ -3364,9 +3364,9 @@
                 <a:ea typeface="Calibri" pitchFamily="34" charset="-122"/>
                 <a:cs typeface="Calibri" pitchFamily="34" charset="-120"/>
               </a:rPr>
-              <a:t>RMB 380B three-year AI transformation; Hydrogen Ion AI doctor tool; Tongyi Qianwen targeting 'Android of AI'; AI healthcare rivalry vs JD and Meituan</a:t>
-            </a:r>
-            <a:endParaRPr lang="en-US" sz="1000" dirty="0"/>
+              <a:t>RMB 380B AI transformation; Meituan Xiaotuan Health Butler launched Apr 14; Alibaba Hydrogen Ion AI for doctors; 75% CS </a:t>
+            </a:r>
+            <a:endParaRPr lang="en-US" sz="950" dirty="0"/>
           </a:p>
         </p:txBody>
       </p:sp>
@@ -3378,7 +3378,7 @@
         </p:nvSpPr>
         <p:spPr>
           <a:xfrm>
-            <a:off x="530352" y="5065776"/>
+            <a:off x="530352" y="4937760"/>
             <a:ext cx="3977640" cy="347472"/>
           </a:xfrm>
           <a:prstGeom prst="rect">
@@ -3395,7 +3395,7 @@
               <a:buNone/>
             </a:pPr>
             <a:r>
-              <a:rPr lang="en-US" sz="950" dirty="0">
+              <a:rPr lang="en-US" sz="900" dirty="0">
                 <a:solidFill>
                   <a:srgbClr val="CBD5E1"/>
                 </a:solidFill>
@@ -3403,9 +3403,9 @@
                 <a:ea typeface="Calibri" pitchFamily="34" charset="-122"/>
                 <a:cs typeface="Calibri" pitchFamily="34" charset="-120"/>
               </a:rPr>
-              <a:t>▶  Stock +94.4% YTD on AI enthusiasm; 700+ gen-AI products filed in China</a:t>
-            </a:r>
-            <a:endParaRPr lang="en-US" sz="950" dirty="0"/>
+              <a:t>▶  Alibaba targets ASI via Tongyi Qianwen; healthcare positioned as next commerce frontier amid e-comme</a:t>
+            </a:r>
+            <a:endParaRPr lang="en-US" sz="900" dirty="0"/>
           </a:p>
         </p:txBody>
       </p:sp>
@@ -3417,8 +3417,8 @@
         </p:nvSpPr>
         <p:spPr>
           <a:xfrm>
-            <a:off x="4828032" y="4151376"/>
-            <a:ext cx="4251960" cy="1389888"/>
+            <a:off x="4828032" y="4041648"/>
+            <a:ext cx="4251960" cy="1335024"/>
           </a:xfrm>
           <a:prstGeom prst="rect">
             <a:avLst/>
@@ -3446,8 +3446,8 @@
         </p:nvSpPr>
         <p:spPr>
           <a:xfrm>
-            <a:off x="4828032" y="4151376"/>
-            <a:ext cx="50292" cy="1389888"/>
+            <a:off x="4828032" y="4041648"/>
+            <a:ext cx="50292" cy="1335024"/>
           </a:xfrm>
           <a:prstGeom prst="rect">
             <a:avLst/>
@@ -3471,8 +3471,8 @@
         </p:nvSpPr>
         <p:spPr>
           <a:xfrm>
-            <a:off x="4992624" y="4242816"/>
-            <a:ext cx="3977640" cy="292608"/>
+            <a:off x="4992624" y="4114800"/>
+            <a:ext cx="3977640" cy="274320"/>
           </a:xfrm>
           <a:prstGeom prst="rect">
             <a:avLst/>
@@ -3488,7 +3488,7 @@
               <a:buNone/>
             </a:pPr>
             <a:r>
-              <a:rPr lang="en-US" sz="1200" b="1" dirty="0">
+              <a:rPr lang="en-US" sz="1150" b="1" dirty="0">
                 <a:solidFill>
                   <a:srgbClr val="FFDA00"/>
                 </a:solidFill>
@@ -3496,9 +3496,9 @@
                 <a:ea typeface="Trebuchet MS" pitchFamily="34" charset="-122"/>
                 <a:cs typeface="Trebuchet MS" pitchFamily="34" charset="-120"/>
               </a:rPr>
-              <a:t>Dollar General  USA</a:t>
-            </a:r>
-            <a:endParaRPr lang="en-US" sz="1200" dirty="0"/>
+              <a:t>Douyin/ByteDance  China/Global</a:t>
+            </a:r>
+            <a:endParaRPr lang="en-US" sz="1150" dirty="0"/>
           </a:p>
         </p:txBody>
       </p:sp>
@@ -3510,7 +3510,7 @@
         </p:nvSpPr>
         <p:spPr>
           <a:xfrm>
-            <a:off x="4992624" y="4562856"/>
+            <a:off x="4992624" y="4425696"/>
             <a:ext cx="3977640" cy="475488"/>
           </a:xfrm>
           <a:prstGeom prst="rect">
@@ -3530,7 +3530,7 @@
               <a:buNone/>
             </a:pPr>
             <a:r>
-              <a:rPr lang="en-US" sz="1000" dirty="0">
+              <a:rPr lang="en-US" sz="950" dirty="0">
                 <a:solidFill>
                   <a:srgbClr val="FFFFFF"/>
                 </a:solidFill>
@@ -3538,9 +3538,9 @@
                 <a:ea typeface="Calibri" pitchFamily="34" charset="-122"/>
                 <a:cs typeface="Calibri" pitchFamily="34" charset="-120"/>
               </a:rPr>
-              <a:t>AI-enabled in-store audio across ~6,000 stores (partnership: QSIC); expands to 12,000 stores with AI audio by Q2 2026 across 48 states</a:t>
-            </a:r>
-            <a:endParaRPr lang="en-US" sz="1000" dirty="0"/>
+              <a:t>AI live commerce at ¥7T scale; Volcengine ~49% China LLM cloud market; luxury live commerce +40% YoY; TikTok strategic r</a:t>
+            </a:r>
+            <a:endParaRPr lang="en-US" sz="950" dirty="0"/>
           </a:p>
         </p:txBody>
       </p:sp>
@@ -3552,7 +3552,7 @@
         </p:nvSpPr>
         <p:spPr>
           <a:xfrm>
-            <a:off x="4992624" y="5065776"/>
+            <a:off x="4992624" y="4937760"/>
             <a:ext cx="3977640" cy="347472"/>
           </a:xfrm>
           <a:prstGeom prst="rect">
@@ -3569,7 +3569,7 @@
               <a:buNone/>
             </a:pPr>
             <a:r>
-              <a:rPr lang="en-US" sz="950" dirty="0">
+              <a:rPr lang="en-US" sz="900" dirty="0">
                 <a:solidFill>
                   <a:srgbClr val="CBD5E1"/>
                 </a:solidFill>
@@ -3577,9 +3577,9 @@
                 <a:ea typeface="Calibri" pitchFamily="34" charset="-122"/>
                 <a:cs typeface="Calibri" pitchFamily="34" charset="-120"/>
               </a:rPr>
-              <a:t>▶  Doubles existing audio footprint; accountable data-driven advertising for brand partners</a:t>
-            </a:r>
-            <a:endParaRPr lang="en-US" sz="950" dirty="0"/>
+              <a:t>▶  Douyin GMV ~RMB 3.5T in 2024 (+30% YoY); Doubao powers AI ad-creative, recommendations, enterprise c</a:t>
+            </a:r>
+            <a:endParaRPr lang="en-US" sz="900" dirty="0"/>
           </a:p>
         </p:txBody>
       </p:sp>
@@ -3751,8 +3751,8 @@
         </p:nvSpPr>
         <p:spPr>
           <a:xfrm>
-            <a:off x="411480" y="841248"/>
-            <a:ext cx="8321040" cy="1298448"/>
+            <a:off x="411480" y="822960"/>
+            <a:ext cx="8321040" cy="1335024"/>
           </a:xfrm>
           <a:prstGeom prst="rect">
             <a:avLst/>
@@ -3783,8 +3783,8 @@
         </p:nvSpPr>
         <p:spPr>
           <a:xfrm>
-            <a:off x="411480" y="841248"/>
-            <a:ext cx="54864" cy="1298448"/>
+            <a:off x="411480" y="822960"/>
+            <a:ext cx="54864" cy="1335024"/>
           </a:xfrm>
           <a:prstGeom prst="rect">
             <a:avLst/>
@@ -3808,7 +3808,7 @@
         </p:nvSpPr>
         <p:spPr>
           <a:xfrm>
-            <a:off x="502920" y="932688"/>
+            <a:off x="502920" y="914400"/>
             <a:ext cx="384048" cy="384048"/>
           </a:xfrm>
           <a:prstGeom prst="rect">
@@ -3833,7 +3833,7 @@
         </p:nvSpPr>
         <p:spPr>
           <a:xfrm>
-            <a:off x="502920" y="932688"/>
+            <a:off x="502920" y="914400"/>
             <a:ext cx="384048" cy="384048"/>
           </a:xfrm>
           <a:prstGeom prst="rect">
@@ -3872,8 +3872,8 @@
         </p:nvSpPr>
         <p:spPr>
           <a:xfrm>
-            <a:off x="1024128" y="932688"/>
-            <a:ext cx="7498080" cy="347472"/>
+            <a:off x="1024128" y="914400"/>
+            <a:ext cx="7498080" cy="329184"/>
           </a:xfrm>
           <a:prstGeom prst="rect">
             <a:avLst/>
@@ -3897,7 +3897,7 @@
                 <a:ea typeface="Trebuchet MS" pitchFamily="34" charset="-122"/>
                 <a:cs typeface="Trebuchet MS" pitchFamily="34" charset="-120"/>
               </a:rPr>
-              <a:t>Walmart DSL Rollout — In-Store Digitalization at Hyperscale</a:t>
+              <a:t>Walmart's Universal Commerce Protocol — Becoming the Default AI Shopping Layer</a:t>
             </a:r>
             <a:endParaRPr lang="en-US" sz="1200" dirty="0"/>
           </a:p>
@@ -3911,8 +3911,8 @@
         </p:nvSpPr>
         <p:spPr>
           <a:xfrm>
-            <a:off x="1024128" y="1316736"/>
-            <a:ext cx="3931920" cy="320040"/>
+            <a:off x="1024128" y="1280160"/>
+            <a:ext cx="3931920" cy="347472"/>
           </a:xfrm>
           <a:prstGeom prst="rect">
             <a:avLst/>
@@ -3928,7 +3928,7 @@
               <a:buNone/>
             </a:pPr>
             <a:r>
-              <a:rPr lang="en-US" sz="1000" dirty="0">
+              <a:rPr lang="en-US" sz="950" dirty="0">
                 <a:solidFill>
                   <a:srgbClr val="334155"/>
                 </a:solidFill>
@@ -3936,9 +3936,9 @@
                 <a:ea typeface="Calibri" pitchFamily="34" charset="-122"/>
                 <a:cs typeface="Calibri" pitchFamily="34" charset="-120"/>
               </a:rPr>
-              <a:t>Highlight: 4,600+ U.S. stores by year-end; ~€1B VusionGroup contract; 75% associate time savings on pricing tasks</a:t>
-            </a:r>
-            <a:endParaRPr lang="en-US" sz="1000" dirty="0"/>
+              <a:t>Highlight: Walmart joined UCP with Google, Shopify &amp; Target; commerce embedded in ChatGPT and Gemini with checkout integration; Spa</a:t>
+            </a:r>
+            <a:endParaRPr lang="en-US" sz="950" dirty="0"/>
           </a:p>
         </p:txBody>
       </p:sp>
@@ -3950,8 +3950,8 @@
         </p:nvSpPr>
         <p:spPr>
           <a:xfrm>
-            <a:off x="5074920" y="1316736"/>
-            <a:ext cx="3474720" cy="320040"/>
+            <a:off x="5074920" y="1280160"/>
+            <a:ext cx="3474720" cy="347472"/>
           </a:xfrm>
           <a:prstGeom prst="rect">
             <a:avLst/>
@@ -3967,7 +3967,7 @@
               <a:buNone/>
             </a:pPr>
             <a:r>
-              <a:rPr lang="en-US" sz="1000" dirty="0">
+              <a:rPr lang="en-US" sz="950" dirty="0">
                 <a:solidFill>
                   <a:srgbClr val="334155"/>
                 </a:solidFill>
@@ -3975,9 +3975,9 @@
                 <a:ea typeface="Calibri" pitchFamily="34" charset="-122"/>
                 <a:cs typeface="Calibri" pitchFamily="34" charset="-120"/>
               </a:rPr>
-              <a:t>Tech: VusionEdge e-ink labels + VusionCloud SaaS; Pick-to-light &amp; Stock-to-light LED fulfillment; closed system, no customer data</a:t>
-            </a:r>
-            <a:endParaRPr lang="en-US" sz="1000" dirty="0"/>
+              <a:t>Tech: Standardised API layer (UCP) connecting external LLMs to Walmart discovery, purchase, loyalty, post-purchase flows; prop</a:t>
+            </a:r>
+            <a:endParaRPr lang="en-US" sz="950" dirty="0"/>
           </a:p>
         </p:txBody>
       </p:sp>
@@ -3989,7 +3989,7 @@
         </p:nvSpPr>
         <p:spPr>
           <a:xfrm>
-            <a:off x="1024128" y="1682496"/>
+            <a:off x="1024128" y="1691640"/>
             <a:ext cx="7498080" cy="347472"/>
           </a:xfrm>
           <a:prstGeom prst="rect">
@@ -4006,7 +4006,7 @@
               <a:buNone/>
             </a:pPr>
             <a:r>
-              <a:rPr lang="en-US" sz="1000" i="1" dirty="0">
+              <a:rPr lang="en-US" sz="950" i="1" dirty="0">
                 <a:solidFill>
                   <a:srgbClr val="64748B"/>
                 </a:solidFill>
@@ -4014,9 +4014,9 @@
                 <a:ea typeface="Calibri" pitchFamily="34" charset="-122"/>
                 <a:cs typeface="Calibri" pitchFamily="34" charset="-120"/>
               </a:rPr>
-              <a:t>Business Value: Eliminates pricing discrepancies, frees labor for customer service; legislative risk requires proactive trust communications</a:t>
-            </a:r>
-            <a:endParaRPr lang="en-US" sz="1000" dirty="0"/>
+              <a:t>Business Value: Collapses AI-mediated intent to completed purchase; creates self-reinforcing data flywheel; retailers not integrated int</a:t>
+            </a:r>
+            <a:endParaRPr lang="en-US" sz="950" dirty="0"/>
           </a:p>
         </p:txBody>
       </p:sp>
@@ -4029,7 +4029,7 @@
         <p:spPr>
           <a:xfrm>
             <a:off x="411480" y="2304288"/>
-            <a:ext cx="8321040" cy="1298448"/>
+            <a:ext cx="8321040" cy="1335024"/>
           </a:xfrm>
           <a:prstGeom prst="rect">
             <a:avLst/>
@@ -4061,7 +4061,7 @@
         <p:spPr>
           <a:xfrm>
             <a:off x="411480" y="2304288"/>
-            <a:ext cx="54864" cy="1298448"/>
+            <a:ext cx="54864" cy="1335024"/>
           </a:xfrm>
           <a:prstGeom prst="rect">
             <a:avLst/>
@@ -4150,7 +4150,7 @@
         <p:spPr>
           <a:xfrm>
             <a:off x="1024128" y="2395728"/>
-            <a:ext cx="7498080" cy="347472"/>
+            <a:ext cx="7498080" cy="329184"/>
           </a:xfrm>
           <a:prstGeom prst="rect">
             <a:avLst/>
@@ -4174,7 +4174,7 @@
                 <a:ea typeface="Trebuchet MS" pitchFamily="34" charset="-122"/>
                 <a:cs typeface="Trebuchet MS" pitchFamily="34" charset="-120"/>
               </a:rPr>
-              <a:t>Amazon Project Kobe — AI-Orchestrated Physical-Digital Retail Fusion</a:t>
+              <a:t>Amazon Project Kobe — AI-Native Physical Retail at Supercenter Scale</a:t>
             </a:r>
             <a:endParaRPr lang="en-US" sz="1200" dirty="0"/>
           </a:p>
@@ -4188,8 +4188,8 @@
         </p:nvSpPr>
         <p:spPr>
           <a:xfrm>
-            <a:off x="1024128" y="2779776"/>
-            <a:ext cx="3931920" cy="320040"/>
+            <a:off x="1024128" y="2761488"/>
+            <a:ext cx="3931920" cy="347472"/>
           </a:xfrm>
           <a:prstGeom prst="rect">
             <a:avLst/>
@@ -4205,7 +4205,7 @@
               <a:buNone/>
             </a:pPr>
             <a:r>
-              <a:rPr lang="en-US" sz="1000" dirty="0">
+              <a:rPr lang="en-US" sz="950" dirty="0">
                 <a:solidFill>
                   <a:srgbClr val="334155"/>
                 </a:solidFill>
@@ -4213,9 +4213,9 @@
                 <a:ea typeface="Calibri" pitchFamily="34" charset="-122"/>
                 <a:cs typeface="Calibri" pitchFamily="34" charset="-120"/>
               </a:rPr>
-              <a:t>Highlight: 225,000 sq ft superstores embedding AutoStore robotics + AI assistant 'Frida'; ~250,000 SKUs — 2x typical Walmart</a:t>
-            </a:r>
-            <a:endParaRPr lang="en-US" sz="1000" dirty="0"/>
+              <a:t>Highlight: First Kobe store live (Orland Park, IL); 200K sq ft with 100K sq ft embedded AI warehouse; 250,000 SKUs; Blue Jay robots</a:t>
+            </a:r>
+            <a:endParaRPr lang="en-US" sz="950" dirty="0"/>
           </a:p>
         </p:txBody>
       </p:sp>
@@ -4227,8 +4227,8 @@
         </p:nvSpPr>
         <p:spPr>
           <a:xfrm>
-            <a:off x="5074920" y="2779776"/>
-            <a:ext cx="3474720" cy="320040"/>
+            <a:off x="5074920" y="2761488"/>
+            <a:ext cx="3474720" cy="347472"/>
           </a:xfrm>
           <a:prstGeom prst="rect">
             <a:avLst/>
@@ -4244,7 +4244,7 @@
               <a:buNone/>
             </a:pPr>
             <a:r>
-              <a:rPr lang="en-US" sz="1000" dirty="0">
+              <a:rPr lang="en-US" sz="950" dirty="0">
                 <a:solidFill>
                   <a:srgbClr val="334155"/>
                 </a:solidFill>
@@ -4252,9 +4252,9 @@
                 <a:ea typeface="Calibri" pitchFamily="34" charset="-122"/>
                 <a:cs typeface="Calibri" pitchFamily="34" charset="-120"/>
               </a:rPr>
-              <a:t>Tech: AutoStore grid robotics; Frida AI category manager; Orbital multi-temp system (2 years out); single-building in-store + delivery fulfillment</a:t>
-            </a:r>
-            <a:endParaRPr lang="en-US" sz="1000" dirty="0"/>
+              <a:t>Tech: Proteus &amp; Sparrow robots for fulfillment; Blue Jay multi-arm system collapses 3 lines into 1; Project Eluna processes re</a:t>
+            </a:r>
+            <a:endParaRPr lang="en-US" sz="950" dirty="0"/>
           </a:p>
         </p:txBody>
       </p:sp>
@@ -4266,7 +4266,7 @@
         </p:nvSpPr>
         <p:spPr>
           <a:xfrm>
-            <a:off x="1024128" y="3145536"/>
+            <a:off x="1024128" y="3172968"/>
             <a:ext cx="7498080" cy="347472"/>
           </a:xfrm>
           <a:prstGeom prst="rect">
@@ -4283,7 +4283,7 @@
               <a:buNone/>
             </a:pPr>
             <a:r>
-              <a:rPr lang="en-US" sz="1000" i="1" dirty="0">
+              <a:rPr lang="en-US" sz="950" i="1" dirty="0">
                 <a:solidFill>
                   <a:srgbClr val="64748B"/>
                 </a:solidFill>
@@ -4291,9 +4291,9 @@
                 <a:ea typeface="Calibri" pitchFamily="34" charset="-122"/>
                 <a:cs typeface="Calibri" pitchFamily="34" charset="-120"/>
               </a:rPr>
-              <a:t>Business Value: Targets Walmart's 21% U.S. grocery share from Amazon's 3%; 12% higher fulfillment cost signals long-horizon bet; ROI discipline required</a:t>
-            </a:r>
-            <a:endParaRPr lang="en-US" sz="1000" dirty="0"/>
+              <a:t>Business Value: Each store serves as retail revenue surface and last-mile hub; 12% higher fulfillment cost currently but foundational fo</a:t>
+            </a:r>
+            <a:endParaRPr lang="en-US" sz="950" dirty="0"/>
           </a:p>
         </p:txBody>
       </p:sp>
@@ -4305,8 +4305,8 @@
         </p:nvSpPr>
         <p:spPr>
           <a:xfrm>
-            <a:off x="411480" y="3767328"/>
-            <a:ext cx="8321040" cy="1298448"/>
+            <a:off x="411480" y="3785616"/>
+            <a:ext cx="8321040" cy="1335024"/>
           </a:xfrm>
           <a:prstGeom prst="rect">
             <a:avLst/>
@@ -4337,8 +4337,8 @@
         </p:nvSpPr>
         <p:spPr>
           <a:xfrm>
-            <a:off x="411480" y="3767328"/>
-            <a:ext cx="54864" cy="1298448"/>
+            <a:off x="411480" y="3785616"/>
+            <a:ext cx="54864" cy="1335024"/>
           </a:xfrm>
           <a:prstGeom prst="rect">
             <a:avLst/>
@@ -4362,7 +4362,7 @@
         </p:nvSpPr>
         <p:spPr>
           <a:xfrm>
-            <a:off x="502920" y="3858768"/>
+            <a:off x="502920" y="3877056"/>
             <a:ext cx="384048" cy="384048"/>
           </a:xfrm>
           <a:prstGeom prst="rect">
@@ -4387,7 +4387,7 @@
         </p:nvSpPr>
         <p:spPr>
           <a:xfrm>
-            <a:off x="502920" y="3858768"/>
+            <a:off x="502920" y="3877056"/>
             <a:ext cx="384048" cy="384048"/>
           </a:xfrm>
           <a:prstGeom prst="rect">
@@ -4426,8 +4426,8 @@
         </p:nvSpPr>
         <p:spPr>
           <a:xfrm>
-            <a:off x="1024128" y="3858768"/>
-            <a:ext cx="7498080" cy="347472"/>
+            <a:off x="1024128" y="3877056"/>
+            <a:ext cx="7498080" cy="329184"/>
           </a:xfrm>
           <a:prstGeom prst="rect">
             <a:avLst/>
@@ -4451,7 +4451,7 @@
                 <a:ea typeface="Trebuchet MS" pitchFamily="34" charset="-122"/>
                 <a:cs typeface="Trebuchet MS" pitchFamily="34" charset="-120"/>
               </a:rPr>
-              <a:t>Sephora × OpenAI — Agentic Commerce and the New Discovery Layer</a:t>
+              <a:t>Sephora × OpenAI — Conversational Commerce Meets Beauty Expertise at Scale</a:t>
             </a:r>
             <a:endParaRPr lang="en-US" sz="1200" dirty="0"/>
           </a:p>
@@ -4466,7 +4466,7 @@
         <p:spPr>
           <a:xfrm>
             <a:off x="1024128" y="4242816"/>
-            <a:ext cx="3931920" cy="320040"/>
+            <a:ext cx="3931920" cy="347472"/>
           </a:xfrm>
           <a:prstGeom prst="rect">
             <a:avLst/>
@@ -4482,7 +4482,7 @@
               <a:buNone/>
             </a:pPr>
             <a:r>
-              <a:rPr lang="en-US" sz="1000" dirty="0">
+              <a:rPr lang="en-US" sz="950" dirty="0">
                 <a:solidFill>
                   <a:srgbClr val="334155"/>
                 </a:solidFill>
@@ -4490,9 +4490,9 @@
                 <a:ea typeface="Calibri" pitchFamily="34" charset="-122"/>
                 <a:cs typeface="Calibri" pitchFamily="34" charset="-120"/>
               </a:rPr>
-              <a:t>Highlight: ChatGPT app (Mar 2026): personalized beauty advice, Beauty Insider integration; checkout to follow; Shoptalk Spring keynote</a:t>
-            </a:r>
-            <a:endParaRPr lang="en-US" sz="1000" dirty="0"/>
+              <a:t>Highlight: Sephora launched ChatGPT shopping app for 80M+ Beauty Insider members in US; loyalty benefits, personalised recs, and AI</a:t>
+            </a:r>
+            <a:endParaRPr lang="en-US" sz="950" dirty="0"/>
           </a:p>
         </p:txBody>
       </p:sp>
@@ -4505,7 +4505,7 @@
         <p:spPr>
           <a:xfrm>
             <a:off x="5074920" y="4242816"/>
-            <a:ext cx="3474720" cy="320040"/>
+            <a:ext cx="3474720" cy="347472"/>
           </a:xfrm>
           <a:prstGeom prst="rect">
             <a:avLst/>
@@ -4521,7 +4521,7 @@
               <a:buNone/>
             </a:pPr>
             <a:r>
-              <a:rPr lang="en-US" sz="1000" dirty="0">
+              <a:rPr lang="en-US" sz="950" dirty="0">
                 <a:solidFill>
                   <a:srgbClr val="334155"/>
                 </a:solidFill>
@@ -4529,9 +4529,9 @@
                 <a:ea typeface="Calibri" pitchFamily="34" charset="-122"/>
                 <a:cs typeface="Calibri" pitchFamily="34" charset="-120"/>
               </a:rPr>
-              <a:t>Tech: Natural-language product discovery via ChatGPT; loyalty data integration for personalization; new retail media layer via sponsored AI experiences</a:t>
-            </a:r>
-            <a:endParaRPr lang="en-US" sz="1000" dirty="0"/>
+              <a:t>Tech: ChatGPT app pulls from Beauty Insider profiles for personalisation; conversational prompts routed through Sephora catalo</a:t>
+            </a:r>
+            <a:endParaRPr lang="en-US" sz="950" dirty="0"/>
           </a:p>
         </p:txBody>
       </p:sp>
@@ -4543,7 +4543,7 @@
         </p:nvSpPr>
         <p:spPr>
           <a:xfrm>
-            <a:off x="1024128" y="4608576"/>
+            <a:off x="1024128" y="4654296"/>
             <a:ext cx="7498080" cy="347472"/>
           </a:xfrm>
           <a:prstGeom prst="rect">
@@ -4560,7 +4560,7 @@
               <a:buNone/>
             </a:pPr>
             <a:r>
-              <a:rPr lang="en-US" sz="1000" i="1" dirty="0">
+              <a:rPr lang="en-US" sz="950" i="1" dirty="0">
                 <a:solidFill>
                   <a:srgbClr val="64748B"/>
                 </a:solidFill>
@@ -4568,9 +4568,9 @@
                 <a:ea typeface="Calibri" pitchFamily="34" charset="-122"/>
                 <a:cs typeface="Calibri" pitchFamily="34" charset="-120"/>
               </a:rPr>
-              <a:t>Business Value: Brand authority embedded at moment of intent; AI demand forecasting integrates social/influencer signals; competitors (Glossier, Target) already launched</a:t>
-            </a:r>
-            <a:endParaRPr lang="en-US" sz="1000" dirty="0"/>
+              <a:t>Business Value: AI trend forecasting shortened launch cycles 30–40%; intercepts discovery moments before shoppers reach any brand platfo</a:t>
+            </a:r>
+            <a:endParaRPr lang="en-US" sz="950" dirty="0"/>
           </a:p>
         </p:txBody>
       </p:sp>
@@ -4767,7 +4767,7 @@
                 <a:ea typeface="Calibri" pitchFamily="34" charset="-122"/>
                 <a:cs typeface="Calibri" pitchFamily="34" charset="-120"/>
               </a:rPr>
-              <a:t>Grounded in this week's developments  ·  Immediately actionable</a:t>
+              <a:t>Grounded in this week's developments · Immediately actionable</a:t>
             </a:r>
             <a:endParaRPr lang="en-US" sz="1100" dirty="0"/>
           </a:p>
@@ -4860,7 +4860,7 @@
                 <a:ea typeface="Trebuchet MS" pitchFamily="34" charset="-122"/>
                 <a:cs typeface="Trebuchet MS" pitchFamily="34" charset="-120"/>
               </a:rPr>
-              <a:t>01  Enter AI Shopping Agent Channels Now</a:t>
+              <a:t>01  Integrate IKEA Commerce into External AI Agents</a:t>
             </a:r>
             <a:endParaRPr lang="en-US" sz="1100" dirty="0"/>
           </a:p>
@@ -4889,12 +4889,12 @@
           <a:p>
             <a:pPr indent="0" marL="0">
               <a:lnSpc>
-                <a:spcPct val="130000"/>
+                <a:spcPct val="125000"/>
               </a:lnSpc>
               <a:buNone/>
             </a:pPr>
             <a:r>
-              <a:rPr lang="en-US" sz="1000" dirty="0">
+              <a:rPr lang="en-US" sz="950" dirty="0">
                 <a:solidFill>
                   <a:srgbClr val="FFFFFF"/>
                 </a:solidFill>
@@ -4902,9 +4902,9 @@
                 <a:ea typeface="Calibri" pitchFamily="34" charset="-122"/>
                 <a:cs typeface="Calibri" pitchFamily="34" charset="-120"/>
               </a:rPr>
-              <a:t>Pilot ChatGPT or Google Gemini integration for high-frequency categories (storage, lighting, textiles). Ensure product catalog has clean taxonomy, standardized attributes, and real-time inventory APIs for AI readability.</a:t>
-            </a:r>
-            <a:endParaRPr lang="en-US" sz="1000" dirty="0"/>
+              <a:t>Pursue API integration with ChatGPT, Google Gemini, and UCP frameworks now. Prioritise home planning use cases — intercept queries like 'furnish a small living room' with shoppable IKEA recommendations as a direct revenue lever.</a:t>
+            </a:r>
+            <a:endParaRPr lang="en-US" sz="950" dirty="0"/>
           </a:p>
         </p:txBody>
       </p:sp>
@@ -4995,7 +4995,7 @@
                 <a:ea typeface="Trebuchet MS" pitchFamily="34" charset="-122"/>
                 <a:cs typeface="Trebuchet MS" pitchFamily="34" charset="-120"/>
               </a:rPr>
-              <a:t>02  Evaluate Digital Shelf Labels Across Stores</a:t>
+              <a:t>02  Accelerate Digital Shelf Label &amp; AI Inventory Rollout</a:t>
             </a:r>
             <a:endParaRPr lang="en-US" sz="1100" dirty="0"/>
           </a:p>
@@ -5024,12 +5024,12 @@
           <a:p>
             <a:pPr indent="0" marL="0">
               <a:lnSpc>
-                <a:spcPct val="130000"/>
+                <a:spcPct val="125000"/>
               </a:lnSpc>
               <a:buNone/>
             </a:pPr>
             <a:r>
-              <a:rPr lang="en-US" sz="1000" dirty="0">
+              <a:rPr lang="en-US" sz="950" dirty="0">
                 <a:solidFill>
                   <a:srgbClr val="FFFFFF"/>
                 </a:solidFill>
@@ -5037,9 +5037,9 @@
                 <a:ea typeface="Calibri" pitchFamily="34" charset="-122"/>
                 <a:cs typeface="Calibri" pitchFamily="34" charset="-120"/>
               </a:rPr>
-              <a:t>Commission a DSL feasibility study for 5–10 pilot stores using VusionGroup or equivalent. Define success metrics for associate time savings, pricing accuracy, and omnichannel fulfillment speed.</a:t>
-            </a:r>
-            <a:endParaRPr lang="en-US" sz="1000" dirty="0"/>
+              <a:t>Walmart's DSL deployment to 5,200 stores by 2027 resets industry standards. Deploy DSLs with computer-vision inventory tracking across IKEA stores to reduce stock discrepancies, enable dynamic clearance pricing, and improve fulfilment visibility.</a:t>
+            </a:r>
+            <a:endParaRPr lang="en-US" sz="950" dirty="0"/>
           </a:p>
         </p:txBody>
       </p:sp>
@@ -5130,7 +5130,7 @@
                 <a:ea typeface="Trebuchet MS" pitchFamily="34" charset="-122"/>
                 <a:cs typeface="Trebuchet MS" pitchFamily="34" charset="-120"/>
               </a:rPr>
-              <a:t>03  Build AI-Native Room Planning Commerce</a:t>
+              <a:t>03  Build Agentic AI Supply Chain Resilience</a:t>
             </a:r>
             <a:endParaRPr lang="en-US" sz="1100" dirty="0"/>
           </a:p>
@@ -5159,12 +5159,12 @@
           <a:p>
             <a:pPr indent="0" marL="0">
               <a:lnSpc>
-                <a:spcPct val="130000"/>
+                <a:spcPct val="125000"/>
               </a:lnSpc>
               <a:buNone/>
             </a:pPr>
             <a:r>
-              <a:rPr lang="en-US" sz="1000" dirty="0">
+              <a:rPr lang="en-US" sz="950" dirty="0">
                 <a:solidFill>
                   <a:srgbClr val="FFFFFF"/>
                 </a:solidFill>
@@ -5172,9 +5172,9 @@
                 <a:ea typeface="Calibri" pitchFamily="34" charset="-122"/>
                 <a:cs typeface="Calibri" pitchFamily="34" charset="-120"/>
               </a:rPr>
-              <a:t>Leverage generative AI + 3D visualization to create room-planning agents recommending complete IKEA room solutions — converting design expertise into a scalable AI moat competitors cannot replicate.</a:t>
-            </a:r>
-            <a:endParaRPr lang="en-US" sz="1000" dirty="0"/>
+              <a:t>With 25% tariffs on AI chips and 97% geopolitical threat ratings on trade volatility, deploy agentic AI to simulate tariff exposure across IKEA's full bill of materials, dynamically re-route inventory, and qualify alternative suppliers in real time.</a:t>
+            </a:r>
+            <a:endParaRPr lang="en-US" sz="950" dirty="0"/>
           </a:p>
         </p:txBody>
       </p:sp>
@@ -5265,7 +5265,7 @@
                 <a:ea typeface="Trebuchet MS" pitchFamily="34" charset="-122"/>
                 <a:cs typeface="Trebuchet MS" pitchFamily="34" charset="-120"/>
               </a:rPr>
-              <a:t>04  Prioritize AI Supply Chain Resilience</a:t>
+              <a:t>04  Pilot AI-Powered Live Commerce for Home Styling</a:t>
             </a:r>
             <a:endParaRPr lang="en-US" sz="1100" dirty="0"/>
           </a:p>
@@ -5294,12 +5294,12 @@
           <a:p>
             <a:pPr indent="0" marL="0">
               <a:lnSpc>
-                <a:spcPct val="130000"/>
+                <a:spcPct val="125000"/>
               </a:lnSpc>
               <a:buNone/>
             </a:pPr>
             <a:r>
-              <a:rPr lang="en-US" sz="1000" dirty="0">
+              <a:rPr lang="en-US" sz="950" dirty="0">
                 <a:solidFill>
                   <a:srgbClr val="FFFFFF"/>
                 </a:solidFill>
@@ -5307,9 +5307,9 @@
                 <a:ea typeface="Calibri" pitchFamily="34" charset="-122"/>
                 <a:cs typeface="Calibri" pitchFamily="34" charset="-120"/>
               </a:rPr>
-              <a:t>Accelerate AI-powered demand forecasting and inventory rebalancing for import-dependent lines. Deloitte: 95% of execs face rising trade-policy costs; only 30% use AI for supply chain visibility today.</a:t>
-            </a:r>
-            <a:endParaRPr lang="en-US" sz="1000" dirty="0"/>
+              <a:t>Use JD's digital human platform model (90% cost reduction in livestreaming) to pilot AI-assisted home styling livestreams on Douyin (China) and TikTok Shop (Europe), with room config demos and real-time purchase links.</a:t>
+            </a:r>
+            <a:endParaRPr lang="en-US" sz="950" dirty="0"/>
           </a:p>
         </p:txBody>
       </p:sp>
@@ -5400,7 +5400,7 @@
                 <a:ea typeface="Trebuchet MS" pitchFamily="34" charset="-122"/>
                 <a:cs typeface="Trebuchet MS" pitchFamily="34" charset="-120"/>
               </a:rPr>
-              <a:t>05  Build AI Workforce Readiness First</a:t>
+              <a:t>05  Invest in AI Talent Proportionate to Technology Spend</a:t>
             </a:r>
             <a:endParaRPr lang="en-US" sz="1100" dirty="0"/>
           </a:p>
@@ -5429,12 +5429,12 @@
           <a:p>
             <a:pPr indent="0" marL="0">
               <a:lnSpc>
-                <a:spcPct val="130000"/>
+                <a:spcPct val="125000"/>
               </a:lnSpc>
               <a:buNone/>
             </a:pPr>
             <a:r>
-              <a:rPr lang="en-US" sz="1000" dirty="0">
+              <a:rPr lang="en-US" sz="950" dirty="0">
                 <a:solidFill>
                   <a:srgbClr val="FFFFFF"/>
                 </a:solidFill>
@@ -5442,9 +5442,9 @@
                 <a:ea typeface="Calibri" pitchFamily="34" charset="-122"/>
                 <a:cs typeface="Calibri" pitchFamily="34" charset="-120"/>
               </a:rPr>
-              <a:t>Launch structured AI literacy and co-pilot training for store associates, supply chain, and digital teams before deployments scale — mirroring Walmart's 1.6M employee OpenAI certification model.</a:t>
-            </a:r>
-            <a:endParaRPr lang="en-US" sz="1000" dirty="0"/>
+              <a:t>51% of supply chain leaders cite data accuracy as the biggest AI barrier. Establish an IKEA AI Fluency Programme for store managers and supply chain teams — without AI-literate people, technology investment will underdeliver.</a:t>
+            </a:r>
+            <a:endParaRPr lang="en-US" sz="950" dirty="0"/>
           </a:p>
         </p:txBody>
       </p:sp>
@@ -5617,7 +5617,7 @@
         <p:spPr>
           <a:xfrm>
             <a:off x="411480" y="822960"/>
-            <a:ext cx="8321040" cy="841248"/>
+            <a:ext cx="8321040" cy="822960"/>
           </a:xfrm>
           <a:prstGeom prst="rect">
             <a:avLst/>
@@ -5649,7 +5649,7 @@
         <p:spPr>
           <a:xfrm>
             <a:off x="411480" y="822960"/>
-            <a:ext cx="54864" cy="841248"/>
+            <a:ext cx="54864" cy="822960"/>
           </a:xfrm>
           <a:prstGeom prst="rect">
             <a:avLst/>
@@ -5738,7 +5738,7 @@
         <p:spPr>
           <a:xfrm>
             <a:off x="594360" y="896112"/>
-            <a:ext cx="7040880" cy="274320"/>
+            <a:ext cx="7040880" cy="256032"/>
           </a:xfrm>
           <a:prstGeom prst="rect">
             <a:avLst/>
@@ -5754,7 +5754,7 @@
               <a:buNone/>
             </a:pPr>
             <a:r>
-              <a:rPr lang="en-US" sz="1200" b="1" dirty="0">
+              <a:rPr lang="en-US" sz="1150" b="1" dirty="0">
                 <a:solidFill>
                   <a:srgbClr val="111827"/>
                 </a:solidFill>
@@ -5762,9 +5762,9 @@
                 <a:ea typeface="Trebuchet MS" pitchFamily="34" charset="-122"/>
                 <a:cs typeface="Trebuchet MS" pitchFamily="34" charset="-120"/>
               </a:rPr>
-              <a:t>Dynamic Pricing Legislative Risk</a:t>
-            </a:r>
-            <a:endParaRPr lang="en-US" sz="1200" dirty="0"/>
+              <a:t>US Tariff Escalation on AI Hardware</a:t>
+            </a:r>
+            <a:endParaRPr lang="en-US" sz="1150" dirty="0"/>
           </a:p>
         </p:txBody>
       </p:sp>
@@ -5777,7 +5777,7 @@
         <p:spPr>
           <a:xfrm>
             <a:off x="594360" y="1207008"/>
-            <a:ext cx="7863840" cy="384048"/>
+            <a:ext cx="7863840" cy="365760"/>
           </a:xfrm>
           <a:prstGeom prst="rect">
             <a:avLst/>
@@ -5793,7 +5793,7 @@
               <a:buNone/>
             </a:pPr>
             <a:r>
-              <a:rPr lang="en-US" sz="1000" dirty="0">
+              <a:rPr lang="en-US" sz="950" dirty="0">
                 <a:solidFill>
                   <a:srgbClr val="64748B"/>
                 </a:solidFill>
@@ -5801,9 +5801,9 @@
                 <a:ea typeface="Calibri" pitchFamily="34" charset="-122"/>
                 <a:cs typeface="Calibri" pitchFamily="34" charset="-120"/>
               </a:rPr>
-              <a:t>Walmart's DSL rollout triggered U.S. Senate legislation proposing bans in large-format stores. IKEA must monitor EU algorithmic pricing regulation and develop proactive consumer trust communications for any in-store digital pricing deployment.</a:t>
-            </a:r>
-            <a:endParaRPr lang="en-US" sz="1000" dirty="0"/>
+              <a:t>25% tariff on AI chip imports (early April 2026) increases hardware costs for all automation programmes. Review IKEA AI procurement for tariff exposure; identify European and alternative-source suppliers for GPUs and edge compute devices.</a:t>
+            </a:r>
+            <a:endParaRPr lang="en-US" sz="950" dirty="0"/>
           </a:p>
         </p:txBody>
       </p:sp>
@@ -5815,8 +5815,8 @@
         </p:nvSpPr>
         <p:spPr>
           <a:xfrm>
-            <a:off x="411480" y="1810512"/>
-            <a:ext cx="8321040" cy="841248"/>
+            <a:off x="411480" y="1792224"/>
+            <a:ext cx="8321040" cy="822960"/>
           </a:xfrm>
           <a:prstGeom prst="rect">
             <a:avLst/>
@@ -5847,8 +5847,8 @@
         </p:nvSpPr>
         <p:spPr>
           <a:xfrm>
-            <a:off x="411480" y="1810512"/>
-            <a:ext cx="54864" cy="841248"/>
+            <a:off x="411480" y="1792224"/>
+            <a:ext cx="54864" cy="822960"/>
           </a:xfrm>
           <a:prstGeom prst="rect">
             <a:avLst/>
@@ -5872,7 +5872,7 @@
         </p:nvSpPr>
         <p:spPr>
           <a:xfrm>
-            <a:off x="7772400" y="1883664"/>
+            <a:off x="7772400" y="1865376"/>
             <a:ext cx="914400" cy="237744"/>
           </a:xfrm>
           <a:prstGeom prst="rect">
@@ -5897,7 +5897,7 @@
         </p:nvSpPr>
         <p:spPr>
           <a:xfrm>
-            <a:off x="7772400" y="1892808"/>
+            <a:off x="7772400" y="1874520"/>
             <a:ext cx="914400" cy="219456"/>
           </a:xfrm>
           <a:prstGeom prst="rect">
@@ -5936,8 +5936,8 @@
         </p:nvSpPr>
         <p:spPr>
           <a:xfrm>
-            <a:off x="594360" y="1883664"/>
-            <a:ext cx="7040880" cy="274320"/>
+            <a:off x="594360" y="1865376"/>
+            <a:ext cx="7040880" cy="256032"/>
           </a:xfrm>
           <a:prstGeom prst="rect">
             <a:avLst/>
@@ -5953,7 +5953,7 @@
               <a:buNone/>
             </a:pPr>
             <a:r>
-              <a:rPr lang="en-US" sz="1200" b="1" dirty="0">
+              <a:rPr lang="en-US" sz="1150" b="1" dirty="0">
                 <a:solidFill>
                   <a:srgbClr val="111827"/>
                 </a:solidFill>
@@ -5961,9 +5961,9 @@
                 <a:ea typeface="Trebuchet MS" pitchFamily="34" charset="-122"/>
                 <a:cs typeface="Trebuchet MS" pitchFamily="34" charset="-120"/>
               </a:rPr>
-              <a:t>Agentic Commerce Channel Fragmentation</a:t>
-            </a:r>
-            <a:endParaRPr lang="en-US" sz="1200" dirty="0"/>
+              <a:t>AI Investment Outpacing Data Infrastructure Readiness</a:t>
+            </a:r>
+            <a:endParaRPr lang="en-US" sz="1150" dirty="0"/>
           </a:p>
         </p:txBody>
       </p:sp>
@@ -5975,8 +5975,8 @@
         </p:nvSpPr>
         <p:spPr>
           <a:xfrm>
-            <a:off x="594360" y="2194560"/>
-            <a:ext cx="7863840" cy="384048"/>
+            <a:off x="594360" y="2176272"/>
+            <a:ext cx="7863840" cy="365760"/>
           </a:xfrm>
           <a:prstGeom prst="rect">
             <a:avLst/>
@@ -5992,7 +5992,7 @@
               <a:buNone/>
             </a:pPr>
             <a:r>
-              <a:rPr lang="en-US" sz="1000" dirty="0">
+              <a:rPr lang="en-US" sz="950" dirty="0">
                 <a:solidFill>
                   <a:srgbClr val="64748B"/>
                 </a:solidFill>
@@ -6000,9 +6000,9 @@
                 <a:ea typeface="Calibri" pitchFamily="34" charset="-122"/>
                 <a:cs typeface="Calibri" pitchFamily="34" charset="-120"/>
               </a:rPr>
-              <a:t>Divergence between Walmart's open AI ecosystem (Gemini, OpenAI, UCP) and Amazon's closed approach (Rufus) fragments discovery. Retailers absent from AI-mediated channels risk disappearing at the moment of consumer intent.</a:t>
-            </a:r>
-            <a:endParaRPr lang="en-US" sz="1000" dirty="0"/>
+              <a:t>51% of supply chain leaders cite data accuracy as the biggest AI barrier; only 42% have real-time visibility. IKEA's 450+ stores and multi-country manufacturing may face the same constraint. Conduct a data readiness audit before agentic AI deployment.</a:t>
+            </a:r>
+            <a:endParaRPr lang="en-US" sz="950" dirty="0"/>
           </a:p>
         </p:txBody>
       </p:sp>
@@ -6014,8 +6014,8 @@
         </p:nvSpPr>
         <p:spPr>
           <a:xfrm>
-            <a:off x="411480" y="2798064"/>
-            <a:ext cx="8321040" cy="841248"/>
+            <a:off x="411480" y="2761488"/>
+            <a:ext cx="8321040" cy="822960"/>
           </a:xfrm>
           <a:prstGeom prst="rect">
             <a:avLst/>
@@ -6046,8 +6046,8 @@
         </p:nvSpPr>
         <p:spPr>
           <a:xfrm>
-            <a:off x="411480" y="2798064"/>
-            <a:ext cx="54864" cy="841248"/>
+            <a:off x="411480" y="2761488"/>
+            <a:ext cx="54864" cy="822960"/>
           </a:xfrm>
           <a:prstGeom prst="rect">
             <a:avLst/>
@@ -6071,7 +6071,7 @@
         </p:nvSpPr>
         <p:spPr>
           <a:xfrm>
-            <a:off x="7772400" y="2871216"/>
+            <a:off x="7772400" y="2834640"/>
             <a:ext cx="914400" cy="237744"/>
           </a:xfrm>
           <a:prstGeom prst="rect">
@@ -6096,7 +6096,7 @@
         </p:nvSpPr>
         <p:spPr>
           <a:xfrm>
-            <a:off x="7772400" y="2880360"/>
+            <a:off x="7772400" y="2843784"/>
             <a:ext cx="914400" cy="219456"/>
           </a:xfrm>
           <a:prstGeom prst="rect">
@@ -6135,8 +6135,8 @@
         </p:nvSpPr>
         <p:spPr>
           <a:xfrm>
-            <a:off x="594360" y="2871216"/>
-            <a:ext cx="7040880" cy="274320"/>
+            <a:off x="594360" y="2834640"/>
+            <a:ext cx="7040880" cy="256032"/>
           </a:xfrm>
           <a:prstGeom prst="rect">
             <a:avLst/>
@@ -6152,7 +6152,7 @@
               <a:buNone/>
             </a:pPr>
             <a:r>
-              <a:rPr lang="en-US" sz="1200" b="1" dirty="0">
+              <a:rPr lang="en-US" sz="1150" b="1" dirty="0">
                 <a:solidFill>
                   <a:srgbClr val="111827"/>
                 </a:solidFill>
@@ -6160,9 +6160,9 @@
                 <a:ea typeface="Trebuchet MS" pitchFamily="34" charset="-122"/>
                 <a:cs typeface="Trebuchet MS" pitchFamily="34" charset="-120"/>
               </a:rPr>
-              <a:t>AI R&amp;D ROI Discipline Imperative</a:t>
-            </a:r>
-            <a:endParaRPr lang="en-US" sz="1200" dirty="0"/>
+              <a:t>TikTok/ByteDance Regulatory &amp; Governance Uncertainty</a:t>
+            </a:r>
+            <a:endParaRPr lang="en-US" sz="1150" dirty="0"/>
           </a:p>
         </p:txBody>
       </p:sp>
@@ -6174,8 +6174,8 @@
         </p:nvSpPr>
         <p:spPr>
           <a:xfrm>
-            <a:off x="594360" y="3182112"/>
-            <a:ext cx="7863840" cy="384048"/>
+            <a:off x="594360" y="3145536"/>
+            <a:ext cx="7863840" cy="365760"/>
           </a:xfrm>
           <a:prstGeom prst="rect">
             <a:avLst/>
@@ -6191,7 +6191,7 @@
               <a:buNone/>
             </a:pPr>
             <a:r>
-              <a:rPr lang="en-US" sz="1000" dirty="0">
+              <a:rPr lang="en-US" sz="950" dirty="0">
                 <a:solidFill>
                   <a:srgbClr val="64748B"/>
                 </a:solidFill>
@@ -6199,9 +6199,9 @@
                 <a:ea typeface="Calibri" pitchFamily="34" charset="-122"/>
                 <a:cs typeface="Calibri" pitchFamily="34" charset="-120"/>
               </a:rPr>
-              <a:t>Amazon cancelled Blue Jay robotics in under 6 months. As IKEA scales AI investments, stage-gate reviews with explicit ROI metrics are essential to prevent sunk-cost escalation and maintain strategic focus.</a:t>
-            </a:r>
-            <a:endParaRPr lang="en-US" sz="1000" dirty="0"/>
+              <a:t>TikTok is centralising under Beijing leadership amid US ownership talks; EU DSA probes ongoing with $1B+ reserved for fines. Maintain channel diversity for IKEA live commerce — do not over-index on TikTok Shop revenue.</a:t>
+            </a:r>
+            <a:endParaRPr lang="en-US" sz="950" dirty="0"/>
           </a:p>
         </p:txBody>
       </p:sp>
@@ -6213,8 +6213,8 @@
         </p:nvSpPr>
         <p:spPr>
           <a:xfrm>
-            <a:off x="411480" y="3785616"/>
-            <a:ext cx="8321040" cy="841248"/>
+            <a:off x="411480" y="3730752"/>
+            <a:ext cx="8321040" cy="822960"/>
           </a:xfrm>
           <a:prstGeom prst="rect">
             <a:avLst/>
@@ -6245,8 +6245,8 @@
         </p:nvSpPr>
         <p:spPr>
           <a:xfrm>
-            <a:off x="411480" y="3785616"/>
-            <a:ext cx="54864" cy="841248"/>
+            <a:off x="411480" y="3730752"/>
+            <a:ext cx="54864" cy="822960"/>
           </a:xfrm>
           <a:prstGeom prst="rect">
             <a:avLst/>
@@ -6270,7 +6270,7 @@
         </p:nvSpPr>
         <p:spPr>
           <a:xfrm>
-            <a:off x="7772400" y="3858768"/>
+            <a:off x="7772400" y="3803904"/>
             <a:ext cx="914400" cy="237744"/>
           </a:xfrm>
           <a:prstGeom prst="rect">
@@ -6295,7 +6295,7 @@
         </p:nvSpPr>
         <p:spPr>
           <a:xfrm>
-            <a:off x="7772400" y="3867912"/>
+            <a:off x="7772400" y="3813048"/>
             <a:ext cx="914400" cy="219456"/>
           </a:xfrm>
           <a:prstGeom prst="rect">
@@ -6334,8 +6334,8 @@
         </p:nvSpPr>
         <p:spPr>
           <a:xfrm>
-            <a:off x="594360" y="3858768"/>
-            <a:ext cx="7040880" cy="274320"/>
+            <a:off x="594360" y="3803904"/>
+            <a:ext cx="7040880" cy="256032"/>
           </a:xfrm>
           <a:prstGeom prst="rect">
             <a:avLst/>
@@ -6351,7 +6351,7 @@
               <a:buNone/>
             </a:pPr>
             <a:r>
-              <a:rPr lang="en-US" sz="1200" b="1" dirty="0">
+              <a:rPr lang="en-US" sz="1150" b="1" dirty="0">
                 <a:solidFill>
                   <a:srgbClr val="111827"/>
                 </a:solidFill>
@@ -6359,9 +6359,9 @@
                 <a:ea typeface="Trebuchet MS" pitchFamily="34" charset="-122"/>
                 <a:cs typeface="Trebuchet MS" pitchFamily="34" charset="-120"/>
               </a:rPr>
-              <a:t>Data Infrastructure as the Binding Constraint</a:t>
-            </a:r>
-            <a:endParaRPr lang="en-US" sz="1200" dirty="0"/>
+              <a:t>Conversational Commerce Disintermediation Risk</a:t>
+            </a:r>
+            <a:endParaRPr lang="en-US" sz="1150" dirty="0"/>
           </a:p>
         </p:txBody>
       </p:sp>
@@ -6373,8 +6373,8 @@
         </p:nvSpPr>
         <p:spPr>
           <a:xfrm>
-            <a:off x="594360" y="4169664"/>
-            <a:ext cx="7863840" cy="384048"/>
+            <a:off x="594360" y="4114800"/>
+            <a:ext cx="7863840" cy="365760"/>
           </a:xfrm>
           <a:prstGeom prst="rect">
             <a:avLst/>
@@ -6390,7 +6390,7 @@
               <a:buNone/>
             </a:pPr>
             <a:r>
-              <a:rPr lang="en-US" sz="1000" dirty="0">
+              <a:rPr lang="en-US" sz="950" dirty="0">
                 <a:solidFill>
                   <a:srgbClr val="64748B"/>
                 </a:solidFill>
@@ -6398,9 +6398,9 @@
                 <a:ea typeface="Calibri" pitchFamily="34" charset="-122"/>
                 <a:cs typeface="Calibri" pitchFamily="34" charset="-120"/>
               </a:rPr>
-              <a:t>Cloudera (April 14, 2026): 80% of enterprises say AI initiatives are limited by data access, not algorithms. Fragmented IKEA data across POS, CRM, e-commerce, and supply chain is the primary barrier to AI ROI.</a:t>
-            </a:r>
-            <a:endParaRPr lang="en-US" sz="1000" dirty="0"/>
+              <a:t>Retailers not integrated into ChatGPT/Gemini commerce flows risk disappearing at the moment of consumer intent. For IKEA, bedroom or living room furniture queries defaulting to competitors is a present-tense risk, not a future scenario.</a:t>
+            </a:r>
+            <a:endParaRPr lang="en-US" sz="950" dirty="0"/>
           </a:p>
         </p:txBody>
       </p:sp>
@@ -6412,7 +6412,7 @@
         </p:nvSpPr>
         <p:spPr>
           <a:xfrm>
-            <a:off x="502920" y="4462272"/>
+            <a:off x="502920" y="4681728"/>
             <a:ext cx="8138160" cy="0"/>
           </a:xfrm>
           <a:prstGeom prst="line">
@@ -6435,8 +6435,8 @@
         </p:nvSpPr>
         <p:spPr>
           <a:xfrm>
-            <a:off x="502920" y="4553712"/>
-            <a:ext cx="1371600" cy="228600"/>
+            <a:off x="502920" y="4754880"/>
+            <a:ext cx="1371600" cy="201168"/>
           </a:xfrm>
           <a:prstGeom prst="rect">
             <a:avLst/>
@@ -6474,8 +6474,8 @@
         </p:nvSpPr>
         <p:spPr>
           <a:xfrm>
-            <a:off x="502920" y="4773168"/>
-            <a:ext cx="8229600" cy="274320"/>
+            <a:off x="502920" y="4937760"/>
+            <a:ext cx="8229600" cy="228600"/>
           </a:xfrm>
           <a:prstGeom prst="rect">
             <a:avLst/>
@@ -6491,7 +6491,7 @@
               <a:buNone/>
             </a:pPr>
             <a:r>
-              <a:rPr lang="en-US" sz="800" i="1" dirty="0">
+              <a:rPr lang="en-US" sz="750" i="1" dirty="0">
                 <a:solidFill>
                   <a:srgbClr val="64748B"/>
                 </a:solidFill>
@@ -6499,9 +6499,9 @@
                 <a:ea typeface="Calibri" pitchFamily="34" charset="-122"/>
                 <a:cs typeface="Calibri" pitchFamily="34" charset="-120"/>
               </a:rPr>
-              <a:t>Walmart Corp (Mar 2026) · Business Insider Project Kobe (Apr 8, 2026) · CNBC (Mar 2026) · PYMNTS (Apr 2026) · Retail Gazette (Mar 25, 2026) · Yicai Global (Apr 15, 2026) · TMTPOST · Retail Technology Innovation Hub (Apr 14–16, 2026) · MarketsandMarkets (Apr 15, 2026) · Deloitte 2026 Retail Global Outlook · NVIDIA State of AI in Retail 2026 · Cloudera Data Readiness Index (Apr 14, 2026) · eMarketer · ClickZ / Shoptalk Spring 2026</a:t>
-            </a:r>
-            <a:endParaRPr lang="en-US" sz="800" dirty="0"/>
+              <a:t>AI Magazine · PYMNTS · Retail Dive · Business Insider · 247 Wall St. · Artificial Intelligence News · Supply Chain Dive · Yicai Global · TMTPOST · Cosmetics Business · Global Cosmetics News · ClickZ (Shoptalk Spring 2026) · Retail Technology Innovation Hub · eMarketer · Comms8 · Financial Content · Thomson Reuters 2026 Global Trade Report · Deloitte · KPMG · Impinj · Gartner · Everstream Analytics · NRF</a:t>
+            </a:r>
+            <a:endParaRPr lang="en-US" sz="750" dirty="0"/>
           </a:p>
         </p:txBody>
       </p:sp>

</xml_diff>